<commit_message>
Doku/Präsentation: Webhooks im Architektur-Diagramm + aktuelle Zahlen
- Architektur (DE/EN): Umsystem „Webhook-Ziele (ITSM/AWX/Pipelines/Chat)" +
  signierter Webhook-POST-Pfeil im Top-Level-Flowchart ergänzt.
- Präsentation: Zahlen-Folie aktualisiert (106 Releases, 175 Commits, 11.392
  Zeilen, 98 Smoke-Checks, 630+ Übersetzungen, 12 Verwaltungs-Bereiche);
  Feature-Sammlung „Integration & Betrieb" nennt jetzt „Ausgehende Webhooks
  (HMAC-signiert)"; „Außerdem"-Zeile um Webhooks ergänzt. Deck neu erzeugt.

Co-Authored-By: Claude Opus 4.8 <noreply@anthropic.com>
</commit_message>
<xml_diff>
--- a/docs/praesentation/VMware-Kapazitaetsplanung.pptx
+++ b/docs/praesentation/VMware-Kapazitaetsplanung.pptx
@@ -4791,6 +4791,68 @@
                 </a:solidFill>
                 <a:latin typeface="Segoe UI"/>
               </a:rPr>
+              <a:t>Ausgehende Webhooks (HMAC-signiert)</a:t>
+            </a:r>
+          </a:p>
+          <a:p>
+            <a:pPr algn="l">
+              <a:lnSpc>
+                <a:spcPct val="100000"/>
+              </a:lnSpc>
+              <a:spcBef>
+                <a:spcPts val="0"/>
+              </a:spcBef>
+              <a:spcAft>
+                <a:spcPts val="450"/>
+              </a:spcAft>
+            </a:pPr>
+            <a:r>
+              <a:rPr sz="1050" b="1">
+                <a:solidFill>
+                  <a:srgbClr val="34D399"/>
+                </a:solidFill>
+                <a:latin typeface="Segoe UI"/>
+              </a:rPr>
+              <a:t>•  </a:t>
+            </a:r>
+            <a:r>
+              <a:rPr sz="1050" b="0">
+                <a:solidFill>
+                  <a:srgbClr val="F2F5FA"/>
+                </a:solidFill>
+                <a:latin typeface="Segoe UI"/>
+              </a:rPr>
+              <a:t>Lesende v1-API (Bearer-Token)</a:t>
+            </a:r>
+          </a:p>
+          <a:p>
+            <a:pPr algn="l">
+              <a:lnSpc>
+                <a:spcPct val="100000"/>
+              </a:lnSpc>
+              <a:spcBef>
+                <a:spcPts val="0"/>
+              </a:spcBef>
+              <a:spcAft>
+                <a:spcPts val="450"/>
+              </a:spcAft>
+            </a:pPr>
+            <a:r>
+              <a:rPr sz="1050" b="1">
+                <a:solidFill>
+                  <a:srgbClr val="34D399"/>
+                </a:solidFill>
+                <a:latin typeface="Segoe UI"/>
+              </a:rPr>
+              <a:t>•  </a:t>
+            </a:r>
+            <a:r>
+              <a:rPr sz="1050" b="0">
+                <a:solidFill>
+                  <a:srgbClr val="F2F5FA"/>
+                </a:solidFill>
+                <a:latin typeface="Segoe UI"/>
+              </a:rPr>
               <a:t>Multi-vROps + Offline-Import</a:t>
             </a:r>
           </a:p>
@@ -4822,69 +4884,7 @@
                 </a:solidFill>
                 <a:latin typeface="Segoe UI"/>
               </a:rPr>
-              <a:t>Lesende v1-API (Bearer-Token)</a:t>
-            </a:r>
-          </a:p>
-          <a:p>
-            <a:pPr algn="l">
-              <a:lnSpc>
-                <a:spcPct val="100000"/>
-              </a:lnSpc>
-              <a:spcBef>
-                <a:spcPts val="0"/>
-              </a:spcBef>
-              <a:spcAft>
-                <a:spcPts val="450"/>
-              </a:spcAft>
-            </a:pPr>
-            <a:r>
-              <a:rPr sz="1050" b="1">
-                <a:solidFill>
-                  <a:srgbClr val="34D399"/>
-                </a:solidFill>
-                <a:latin typeface="Segoe UI"/>
-              </a:rPr>
-              <a:t>•  </a:t>
-            </a:r>
-            <a:r>
-              <a:rPr sz="1050" b="0">
-                <a:solidFill>
-                  <a:srgbClr val="F2F5FA"/>
-                </a:solidFill>
-                <a:latin typeface="Segoe UI"/>
-              </a:rPr>
-              <a:t>SFTP-Backup · JSON oder SQLite</a:t>
-            </a:r>
-          </a:p>
-          <a:p>
-            <a:pPr algn="l">
-              <a:lnSpc>
-                <a:spcPct val="100000"/>
-              </a:lnSpc>
-              <a:spcBef>
-                <a:spcPts val="0"/>
-              </a:spcBef>
-              <a:spcAft>
-                <a:spcPts val="450"/>
-              </a:spcAft>
-            </a:pPr>
-            <a:r>
-              <a:rPr sz="1050" b="1">
-                <a:solidFill>
-                  <a:srgbClr val="34D399"/>
-                </a:solidFill>
-                <a:latin typeface="Segoe UI"/>
-              </a:rPr>
-              <a:t>•  </a:t>
-            </a:r>
-            <a:r>
-              <a:rPr sz="1050" b="0">
-                <a:solidFill>
-                  <a:srgbClr val="F2F5FA"/>
-                </a:solidFill>
-                <a:latin typeface="Segoe UI"/>
-              </a:rPr>
-              <a:t>/healthz · Proxy-fähig</a:t>
+              <a:t>SFTP-Backup · JSON/SQLite · /healthz</a:t>
             </a:r>
           </a:p>
         </p:txBody>
@@ -8282,7 +8282,7 @@
                 </a:solidFill>
                 <a:latin typeface="Segoe UI"/>
               </a:rPr>
-              <a:t>Hell-/Dunkel-Modus · SFTP-Backup · Mail &amp; Erinnerungen · CSV-Export · Auto-Freigabe · Reviewer-Handbuch · Zeitzone · Blättern</a:t>
+              <a:t>Webhooks · Hell-/Dunkel-Modus · SFTP-Backup · Mail &amp; Erinnerungen · Auto-Freigabe · Reviewer-Handbuch · Zeitzone · Blättern</a:t>
             </a:r>
           </a:p>
         </p:txBody>
@@ -8677,7 +8677,7 @@
                 </a:solidFill>
                 <a:latin typeface="Segoe UI"/>
               </a:rPr>
-              <a:t>105</a:t>
+              <a:t>106</a:t>
             </a:r>
           </a:p>
         </p:txBody>
@@ -8813,7 +8813,7 @@
                 </a:solidFill>
                 <a:latin typeface="Segoe UI"/>
               </a:rPr>
-              <a:t>167</a:t>
+              <a:t>175</a:t>
             </a:r>
           </a:p>
         </p:txBody>
@@ -8949,7 +8949,7 @@
                 </a:solidFill>
                 <a:latin typeface="Segoe UI"/>
               </a:rPr>
-              <a:t>11.114</a:t>
+              <a:t>11.392</a:t>
             </a:r>
           </a:p>
         </p:txBody>
@@ -9221,7 +9221,7 @@
                 </a:solidFill>
                 <a:latin typeface="Segoe UI"/>
               </a:rPr>
-              <a:t>94</a:t>
+              <a:t>98</a:t>
             </a:r>
           </a:p>
         </p:txBody>
@@ -9493,7 +9493,7 @@
                 </a:solidFill>
                 <a:latin typeface="Segoe UI"/>
               </a:rPr>
-              <a:t>620+</a:t>
+              <a:t>630+</a:t>
             </a:r>
           </a:p>
         </p:txBody>
@@ -9629,7 +9629,7 @@
                 </a:solidFill>
                 <a:latin typeface="Segoe UI"/>
               </a:rPr>
-              <a:t>11</a:t>
+              <a:t>12</a:t>
             </a:r>
           </a:p>
         </p:txBody>

</xml_diff>

<commit_message>
Präsentation auf v3.0-Stand: Zahlen und Architektur-Aussagen aktualisiert
Folie 8 „Das Projekt in Zahlen": 110 Releases, 192 Commits, 12.100+
Zeilen Code · API-first (statt „11.392 · 1 Datei"), 105 Smoke-Checks,
660+ Übersetzungen. Folie 9 Fazit: „eine einzige Python-Datei" →
„nur Python-Standardbibliothek", Update = wenige Dateien; Reichweite
nennt den API-first-Vertrag (v3.0) statt nur lesender API.
Deck via python-pptx neu gebaut, Screenshots unverändert (UI gleich).

Co-Authored-By: Claude Opus 4.8 <noreply@anthropic.com>
</commit_message>
<xml_diff>
--- a/docs/praesentation/VMware-Kapazitaetsplanung.pptx
+++ b/docs/praesentation/VMware-Kapazitaetsplanung.pptx
@@ -8677,7 +8677,7 @@
                 </a:solidFill>
                 <a:latin typeface="Segoe UI"/>
               </a:rPr>
-              <a:t>106</a:t>
+              <a:t>110</a:t>
             </a:r>
           </a:p>
         </p:txBody>
@@ -8813,7 +8813,7 @@
                 </a:solidFill>
                 <a:latin typeface="Segoe UI"/>
               </a:rPr>
-              <a:t>175</a:t>
+              <a:t>192</a:t>
             </a:r>
           </a:p>
         </p:txBody>
@@ -8949,7 +8949,7 @@
                 </a:solidFill>
                 <a:latin typeface="Segoe UI"/>
               </a:rPr>
-              <a:t>11.392</a:t>
+              <a:t>12.100+</a:t>
             </a:r>
           </a:p>
         </p:txBody>
@@ -8994,7 +8994,7 @@
                 </a:solidFill>
                 <a:latin typeface="Segoe UI"/>
               </a:rPr>
-              <a:t>Zeilen Code · 1 Datei</a:t>
+              <a:t>Zeilen Code · API-first</a:t>
             </a:r>
           </a:p>
         </p:txBody>
@@ -9221,7 +9221,7 @@
                 </a:solidFill>
                 <a:latin typeface="Segoe UI"/>
               </a:rPr>
-              <a:t>98</a:t>
+              <a:t>105</a:t>
             </a:r>
           </a:p>
         </p:txBody>
@@ -9493,7 +9493,7 @@
                 </a:solidFill>
                 <a:latin typeface="Segoe UI"/>
               </a:rPr>
-              <a:t>630+</a:t>
+              <a:t>660+</a:t>
             </a:r>
           </a:p>
         </p:txBody>
@@ -10069,7 +10069,7 @@
                 </a:solidFill>
                 <a:latin typeface="Segoe UI"/>
               </a:rPr>
-              <a:t>Eine einzige Python-Datei — kein Build, keine Datenbank, keine Fremd-Pakete</a:t>
+              <a:t>Nur Python-Standardbibliothek — kein Build, keine Datenbank, keine Fremd-Pakete</a:t>
             </a:r>
           </a:p>
           <a:p>
@@ -10100,7 +10100,7 @@
                 </a:solidFill>
                 <a:latin typeface="Segoe UI"/>
               </a:rPr>
-              <a:t>Läuft auf jedem RHEL-Host; ein Update = eine Datei austauschen</a:t>
+              <a:t>Läuft auf jedem RHEL-Host; ein Update = wenige Dateien austauschen</a:t>
             </a:r>
           </a:p>
         </p:txBody>
@@ -10452,7 +10452,7 @@
                 </a:solidFill>
                 <a:latin typeface="Segoe UI"/>
               </a:rPr>
-              <a:t>Lesende API für Grafana, CMDB &amp; Co.</a:t>
+              <a:t>API-first (v3.0): eine API für Oberfläche und externe Systeme — Grafana, CMDB &amp; Co.</a:t>
             </a:r>
           </a:p>
         </p:txBody>

</xml_diff>

<commit_message>
Praesentation auf v3.5-Stand: alle 8 Folien-Screenshots + Zahlen
Fuer die Chef-Runde morgen: die Folien-Screenshots (23.07., altes UI)
neu erzeugt in Originalaufloesung 3000x1800 (Retina @2x, dunkles Theme,
Demo-Seed; Detailkarte via #cluster-Deep-Link, API-Doku-Seite mit dem
neuen Ein-Pfadraum-Absatz). Folie 8 aktualisiert: 122 Releases (alle
signiert), 208 Commits, 12.400+ Zeilen API-first, 139 automatisierte
Tests (120 Smoke + 19 Unit), 665+ Uebersetzungen. Folie 7 Feature-Zeile
+ Folie 9 Fazit erwaehnen jetzt Handbuecher im Produkt, Import & Export
und signierte Releases. Deck via python-pptx neu gebaut (10 Folien).

Co-Authored-By: Claude Opus 4.8 <noreply@anthropic.com>
</commit_message>
<xml_diff>
--- a/docs/praesentation/VMware-Kapazitaetsplanung.pptx
+++ b/docs/praesentation/VMware-Kapazitaetsplanung.pptx
@@ -6086,8 +6086,8 @@
         </p:blipFill>
         <p:spPr>
           <a:xfrm>
-            <a:off x="5138928" y="1393088"/>
-            <a:ext cx="6501384" cy="4117543"/>
+            <a:off x="5138928" y="1501445"/>
+            <a:ext cx="6501384" cy="3900830"/>
           </a:xfrm>
           <a:prstGeom prst="rect">
             <a:avLst/>
@@ -6572,8 +6572,8 @@
         </p:blipFill>
         <p:spPr>
           <a:xfrm>
-            <a:off x="5138928" y="2088667"/>
-            <a:ext cx="6501384" cy="2726386"/>
+            <a:off x="5138928" y="1501445"/>
+            <a:ext cx="6501384" cy="3900830"/>
           </a:xfrm>
           <a:prstGeom prst="rect">
             <a:avLst/>
@@ -7058,8 +7058,8 @@
         </p:blipFill>
         <p:spPr>
           <a:xfrm>
-            <a:off x="5138928" y="1393088"/>
-            <a:ext cx="6501384" cy="4117543"/>
+            <a:off x="5138928" y="1501445"/>
+            <a:ext cx="6501384" cy="3900830"/>
           </a:xfrm>
           <a:prstGeom prst="rect">
             <a:avLst/>
@@ -7544,8 +7544,8 @@
         </p:blipFill>
         <p:spPr>
           <a:xfrm>
-            <a:off x="5138928" y="1674815"/>
-            <a:ext cx="6501384" cy="3554089"/>
+            <a:off x="5138928" y="1501445"/>
+            <a:ext cx="6501384" cy="3900830"/>
           </a:xfrm>
           <a:prstGeom prst="rect">
             <a:avLst/>
@@ -7855,7 +7855,7 @@
       </p:sp>
       <p:pic>
         <p:nvPicPr>
-          <p:cNvPr id="5" name="Picture 4" descr="07_vlan.png"/>
+          <p:cNvPr id="5" name="Picture 4" descr="06_storage.png"/>
           <p:cNvPicPr>
             <a:picLocks noChangeAspect="1"/>
           </p:cNvPicPr>
@@ -7869,8 +7869,8 @@
         </p:blipFill>
         <p:spPr>
           <a:xfrm>
-            <a:off x="658368" y="2247272"/>
-            <a:ext cx="3255264" cy="1723375"/>
+            <a:off x="658368" y="2132381"/>
+            <a:ext cx="3255264" cy="1953158"/>
           </a:xfrm>
           <a:prstGeom prst="rect">
             <a:avLst/>
@@ -8011,8 +8011,8 @@
         </p:blipFill>
         <p:spPr>
           <a:xfrm>
-            <a:off x="4462272" y="2199401"/>
-            <a:ext cx="3255264" cy="1819118"/>
+            <a:off x="4462272" y="2132381"/>
+            <a:ext cx="3255264" cy="1953158"/>
           </a:xfrm>
           <a:prstGeom prst="rect">
             <a:avLst/>
@@ -8153,8 +8153,8 @@
         </p:blipFill>
         <p:spPr>
           <a:xfrm>
-            <a:off x="8266175" y="2079722"/>
-            <a:ext cx="3255264" cy="2058475"/>
+            <a:off x="8266175" y="2132381"/>
+            <a:ext cx="3255264" cy="1953158"/>
           </a:xfrm>
           <a:prstGeom prst="rect">
             <a:avLst/>
@@ -8282,7 +8282,7 @@
                 </a:solidFill>
                 <a:latin typeface="Segoe UI"/>
               </a:rPr>
-              <a:t>Webhooks · Hell-/Dunkel-Modus · SFTP-Backup · Mail &amp; Erinnerungen · Auto-Freigabe · Reviewer-Handbuch · Zeitzone · Blättern</a:t>
+              <a:t>Webhooks · Hell-/Dunkel-Modus · SFTP-Backup · Mails &amp; Erinnerungen · Auto-Freigabe · Handbücher im Produkt · Import &amp; Export · signierte Releases</a:t>
             </a:r>
           </a:p>
         </p:txBody>
@@ -8677,7 +8677,7 @@
                 </a:solidFill>
                 <a:latin typeface="Segoe UI"/>
               </a:rPr>
-              <a:t>110</a:t>
+              <a:t>122</a:t>
             </a:r>
           </a:p>
         </p:txBody>
@@ -8722,7 +8722,7 @@
                 </a:solidFill>
                 <a:latin typeface="Segoe UI"/>
               </a:rPr>
-              <a:t>Releases</a:t>
+              <a:t>Releases · alle signiert</a:t>
             </a:r>
           </a:p>
         </p:txBody>
@@ -8813,7 +8813,7 @@
                 </a:solidFill>
                 <a:latin typeface="Segoe UI"/>
               </a:rPr>
-              <a:t>192</a:t>
+              <a:t>208</a:t>
             </a:r>
           </a:p>
         </p:txBody>
@@ -8949,7 +8949,7 @@
                 </a:solidFill>
                 <a:latin typeface="Segoe UI"/>
               </a:rPr>
-              <a:t>12.100+</a:t>
+              <a:t>12.400+</a:t>
             </a:r>
           </a:p>
         </p:txBody>
@@ -9221,7 +9221,7 @@
                 </a:solidFill>
                 <a:latin typeface="Segoe UI"/>
               </a:rPr>
-              <a:t>105</a:t>
+              <a:t>139</a:t>
             </a:r>
           </a:p>
         </p:txBody>
@@ -9266,7 +9266,7 @@
                 </a:solidFill>
                 <a:latin typeface="Segoe UI"/>
               </a:rPr>
-              <a:t>automatisierte Smoke-Checks</a:t>
+              <a:t>automatisierte Tests</a:t>
             </a:r>
           </a:p>
         </p:txBody>
@@ -9493,7 +9493,7 @@
                 </a:solidFill>
                 <a:latin typeface="Segoe UI"/>
               </a:rPr>
-              <a:t>660+</a:t>
+              <a:t>665+</a:t>
             </a:r>
           </a:p>
         </p:txBody>
@@ -10628,7 +10628,7 @@
                 </a:solidFill>
                 <a:latin typeface="Segoe UI"/>
               </a:rPr>
-              <a:t>Über 100 Releases, Reviewer-Handbuch, Architektur-Doku inklusive</a:t>
+              <a:t>Über 120 signierte Releases, Handbücher im Produkt, Architektur-Doku inklusive</a:t>
             </a:r>
           </a:p>
         </p:txBody>

</xml_diff>